<commit_message>
feat: add python strategy deck builder and PowerShell command utility
</commit_message>
<xml_diff>
--- a/product/deck/gcc-atlas-strategy-deck.pptx
+++ b/product/deck/gcc-atlas-strategy-deck.pptx
@@ -3237,8 +3237,8 @@
         </p:nvSpPr>
         <p:spPr>
           <a:xfrm>
-            <a:off x="777240" y="1874519"/>
-            <a:ext cx="10607040" cy="1554480"/>
+            <a:off x="777240" y="1828800"/>
+            <a:ext cx="10607040" cy="1234440"/>
           </a:xfrm>
           <a:prstGeom prst="rect">
             <a:avLst/>
@@ -3260,7 +3260,7 @@
               </a:spcAft>
             </a:pPr>
             <a:r>
-              <a:rPr sz="4400" b="1" i="0">
+              <a:rPr sz="3900" b="1" i="0">
                 <a:solidFill>
                   <a:srgbClr val="EAF1FC"/>
                 </a:solidFill>
@@ -3323,7 +3323,7 @@
         <p:spPr>
           <a:xfrm>
             <a:off x="777240" y="4069080"/>
-            <a:ext cx="3408883" cy="256032"/>
+            <a:ext cx="4045305" cy="256032"/>
           </a:xfrm>
           <a:prstGeom prst="roundRect">
             <a:avLst>
@@ -3368,8 +3368,8 @@
         </p:nvSpPr>
         <p:spPr>
           <a:xfrm>
-            <a:off x="822960" y="4082796"/>
-            <a:ext cx="3445459" cy="228600"/>
+            <a:off x="868680" y="4082796"/>
+            <a:ext cx="4045305" cy="228600"/>
           </a:xfrm>
           <a:prstGeom prst="rect">
             <a:avLst/>
@@ -3410,8 +3410,8 @@
         </p:nvSpPr>
         <p:spPr>
           <a:xfrm>
-            <a:off x="3291840" y="4069080"/>
-            <a:ext cx="3858768" cy="256032"/>
+            <a:off x="6446520" y="4224528"/>
+            <a:ext cx="4572000" cy="256032"/>
           </a:xfrm>
           <a:prstGeom prst="roundRect">
             <a:avLst>
@@ -3456,8 +3456,8 @@
         </p:nvSpPr>
         <p:spPr>
           <a:xfrm>
-            <a:off x="3337560" y="4082796"/>
-            <a:ext cx="3895344" cy="228600"/>
+            <a:off x="6537959" y="4238244"/>
+            <a:ext cx="4572000" cy="228600"/>
           </a:xfrm>
           <a:prstGeom prst="rect">
             <a:avLst/>
@@ -4558,7 +4558,7 @@
         <p:spPr>
           <a:xfrm>
             <a:off x="685800" y="1636776"/>
-            <a:ext cx="1609344" cy="256032"/>
+            <a:ext cx="1938528" cy="256032"/>
           </a:xfrm>
           <a:prstGeom prst="roundRect">
             <a:avLst>
@@ -4603,8 +4603,8 @@
         </p:nvSpPr>
         <p:spPr>
           <a:xfrm>
-            <a:off x="731520" y="1650492"/>
-            <a:ext cx="1645920" cy="228600"/>
+            <a:off x="777240" y="1650492"/>
+            <a:ext cx="1938528" cy="228600"/>
           </a:xfrm>
           <a:prstGeom prst="rect">
             <a:avLst/>
@@ -4736,7 +4736,7 @@
         <p:spPr>
           <a:xfrm>
             <a:off x="6400800" y="1636776"/>
-            <a:ext cx="1984248" cy="256032"/>
+            <a:ext cx="2377440" cy="256032"/>
           </a:xfrm>
           <a:prstGeom prst="roundRect">
             <a:avLst>
@@ -4781,8 +4781,8 @@
         </p:nvSpPr>
         <p:spPr>
           <a:xfrm>
-            <a:off x="6446520" y="1650492"/>
-            <a:ext cx="2020824" cy="228600"/>
+            <a:off x="6492240" y="1650492"/>
+            <a:ext cx="2377440" cy="228600"/>
           </a:xfrm>
           <a:prstGeom prst="rect">
             <a:avLst/>
@@ -4914,7 +4914,7 @@
         <p:spPr>
           <a:xfrm>
             <a:off x="685800" y="3447288"/>
-            <a:ext cx="1834286" cy="256032"/>
+            <a:ext cx="2201875" cy="256032"/>
           </a:xfrm>
           <a:prstGeom prst="roundRect">
             <a:avLst>
@@ -4959,8 +4959,8 @@
         </p:nvSpPr>
         <p:spPr>
           <a:xfrm>
-            <a:off x="731520" y="3461004"/>
-            <a:ext cx="1870862" cy="228600"/>
+            <a:off x="777240" y="3461004"/>
+            <a:ext cx="2201875" cy="228600"/>
           </a:xfrm>
           <a:prstGeom prst="rect">
             <a:avLst/>
@@ -5092,7 +5092,7 @@
         <p:spPr>
           <a:xfrm>
             <a:off x="6400800" y="3447288"/>
-            <a:ext cx="2584094" cy="256032"/>
+            <a:ext cx="3079699" cy="256032"/>
           </a:xfrm>
           <a:prstGeom prst="roundRect">
             <a:avLst>
@@ -5137,8 +5137,8 @@
         </p:nvSpPr>
         <p:spPr>
           <a:xfrm>
-            <a:off x="6446520" y="3461004"/>
-            <a:ext cx="2620670" cy="228600"/>
+            <a:off x="6492240" y="3461004"/>
+            <a:ext cx="3079699" cy="228600"/>
           </a:xfrm>
           <a:prstGeom prst="rect">
             <a:avLst/>
@@ -6115,8 +6115,8 @@
         </p:nvSpPr>
         <p:spPr>
           <a:xfrm>
-            <a:off x="6446520" y="4315968"/>
-            <a:ext cx="731520" cy="320040"/>
+            <a:off x="6446520" y="4224528"/>
+            <a:ext cx="822960" cy="320040"/>
           </a:xfrm>
           <a:prstGeom prst="rect">
             <a:avLst/>
@@ -6157,8 +6157,8 @@
         </p:nvSpPr>
         <p:spPr>
           <a:xfrm>
-            <a:off x="7178040" y="4315968"/>
-            <a:ext cx="4434840" cy="457200"/>
+            <a:off x="7269480" y="4224528"/>
+            <a:ext cx="4343400" cy="512064"/>
           </a:xfrm>
           <a:prstGeom prst="rect">
             <a:avLst/>
@@ -6199,8 +6199,8 @@
         </p:nvSpPr>
         <p:spPr>
           <a:xfrm>
-            <a:off x="6446520" y="4773168"/>
-            <a:ext cx="731520" cy="320040"/>
+            <a:off x="6446520" y="4754880"/>
+            <a:ext cx="822960" cy="320040"/>
           </a:xfrm>
           <a:prstGeom prst="rect">
             <a:avLst/>
@@ -6241,8 +6241,8 @@
         </p:nvSpPr>
         <p:spPr>
           <a:xfrm>
-            <a:off x="7178040" y="4773168"/>
-            <a:ext cx="4434840" cy="457200"/>
+            <a:off x="7269480" y="4754880"/>
+            <a:ext cx="4343400" cy="512064"/>
           </a:xfrm>
           <a:prstGeom prst="rect">
             <a:avLst/>
@@ -6283,8 +6283,8 @@
         </p:nvSpPr>
         <p:spPr>
           <a:xfrm>
-            <a:off x="6446520" y="5230368"/>
-            <a:ext cx="731520" cy="320040"/>
+            <a:off x="6446520" y="5285232"/>
+            <a:ext cx="822960" cy="320040"/>
           </a:xfrm>
           <a:prstGeom prst="rect">
             <a:avLst/>
@@ -6325,8 +6325,8 @@
         </p:nvSpPr>
         <p:spPr>
           <a:xfrm>
-            <a:off x="7178040" y="5230368"/>
-            <a:ext cx="4434840" cy="457200"/>
+            <a:off x="7269480" y="5285232"/>
+            <a:ext cx="4343400" cy="512064"/>
           </a:xfrm>
           <a:prstGeom prst="rect">
             <a:avLst/>
@@ -6367,8 +6367,8 @@
         </p:nvSpPr>
         <p:spPr>
           <a:xfrm>
-            <a:off x="6446520" y="5687568"/>
-            <a:ext cx="731520" cy="320040"/>
+            <a:off x="6446520" y="5815583"/>
+            <a:ext cx="822960" cy="320040"/>
           </a:xfrm>
           <a:prstGeom prst="rect">
             <a:avLst/>
@@ -6409,8 +6409,8 @@
         </p:nvSpPr>
         <p:spPr>
           <a:xfrm>
-            <a:off x="7178040" y="5687568"/>
-            <a:ext cx="4434840" cy="457200"/>
+            <a:off x="7269480" y="5815583"/>
+            <a:ext cx="4343400" cy="512064"/>
           </a:xfrm>
           <a:prstGeom prst="rect">
             <a:avLst/>
@@ -8876,7 +8876,7 @@
         <p:spPr>
           <a:xfrm>
             <a:off x="685800" y="1810512"/>
-            <a:ext cx="1759305" cy="256032"/>
+            <a:ext cx="2114092" cy="256032"/>
           </a:xfrm>
           <a:prstGeom prst="roundRect">
             <a:avLst>
@@ -8921,8 +8921,8 @@
         </p:nvSpPr>
         <p:spPr>
           <a:xfrm>
-            <a:off x="731520" y="1824228"/>
-            <a:ext cx="1795881" cy="228600"/>
+            <a:off x="777240" y="1824228"/>
+            <a:ext cx="2114092" cy="228600"/>
           </a:xfrm>
           <a:prstGeom prst="rect">
             <a:avLst/>
@@ -9273,7 +9273,7 @@
         <p:spPr>
           <a:xfrm>
             <a:off x="4480560" y="1810512"/>
-            <a:ext cx="1459382" cy="256032"/>
+            <a:ext cx="1762963" cy="256032"/>
           </a:xfrm>
           <a:prstGeom prst="roundRect">
             <a:avLst>
@@ -9318,8 +9318,8 @@
         </p:nvSpPr>
         <p:spPr>
           <a:xfrm>
-            <a:off x="4526280" y="1824228"/>
-            <a:ext cx="1495958" cy="228600"/>
+            <a:off x="4572000" y="1824228"/>
+            <a:ext cx="1762963" cy="228600"/>
           </a:xfrm>
           <a:prstGeom prst="rect">
             <a:avLst/>
@@ -9642,7 +9642,7 @@
         <p:spPr>
           <a:xfrm>
             <a:off x="8275319" y="1810512"/>
-            <a:ext cx="1459382" cy="256032"/>
+            <a:ext cx="1762963" cy="256032"/>
           </a:xfrm>
           <a:prstGeom prst="roundRect">
             <a:avLst>
@@ -9687,8 +9687,8 @@
         </p:nvSpPr>
         <p:spPr>
           <a:xfrm>
-            <a:off x="8321040" y="1824228"/>
-            <a:ext cx="1495958" cy="228600"/>
+            <a:off x="8366759" y="1824228"/>
+            <a:ext cx="1762963" cy="228600"/>
           </a:xfrm>
           <a:prstGeom prst="rect">
             <a:avLst/>
@@ -13600,7 +13600,7 @@
         <p:spPr>
           <a:xfrm>
             <a:off x="6537960" y="5440680"/>
-            <a:ext cx="3558844" cy="256032"/>
+            <a:ext cx="4220870" cy="256032"/>
           </a:xfrm>
           <a:prstGeom prst="roundRect">
             <a:avLst>
@@ -13645,8 +13645,8 @@
         </p:nvSpPr>
         <p:spPr>
           <a:xfrm>
-            <a:off x="6583680" y="5454396"/>
-            <a:ext cx="3595420" cy="228600"/>
+            <a:off x="6629400" y="5454396"/>
+            <a:ext cx="4220870" cy="228600"/>
           </a:xfrm>
           <a:prstGeom prst="rect">
             <a:avLst/>
@@ -15335,7 +15335,7 @@
         <p:spPr>
           <a:xfrm>
             <a:off x="502920" y="1417320"/>
-            <a:ext cx="6903720" cy="2706624"/>
+            <a:ext cx="6903720" cy="2596896"/>
           </a:xfrm>
           <a:prstGeom prst="roundRect">
             <a:avLst>
@@ -15391,7 +15391,7 @@
         <p:spPr>
           <a:xfrm>
             <a:off x="576072" y="1472184"/>
-            <a:ext cx="6757416" cy="2249424"/>
+            <a:ext cx="6757416" cy="2139696"/>
           </a:xfrm>
           <a:prstGeom prst="rect">
             <a:avLst/>
@@ -15406,7 +15406,7 @@
         </p:nvSpPr>
         <p:spPr>
           <a:xfrm>
-            <a:off x="576072" y="3840480"/>
+            <a:off x="576072" y="3730752"/>
             <a:ext cx="6757416" cy="256032"/>
           </a:xfrm>
           <a:prstGeom prst="rect">
@@ -15449,7 +15449,7 @@
         <p:spPr>
           <a:xfrm>
             <a:off x="7543800" y="1417320"/>
-            <a:ext cx="4142232" cy="2706624"/>
+            <a:ext cx="4142232" cy="2596896"/>
           </a:xfrm>
           <a:prstGeom prst="roundRect">
             <a:avLst>
@@ -15505,7 +15505,7 @@
         <p:spPr>
           <a:xfrm>
             <a:off x="7616952" y="1472184"/>
-            <a:ext cx="3995928" cy="2249424"/>
+            <a:ext cx="3995928" cy="2139696"/>
           </a:xfrm>
           <a:prstGeom prst="rect">
             <a:avLst/>
@@ -15520,7 +15520,7 @@
         </p:nvSpPr>
         <p:spPr>
           <a:xfrm>
-            <a:off x="7616952" y="3840480"/>
+            <a:off x="7616952" y="3730752"/>
             <a:ext cx="3995928" cy="256032"/>
           </a:xfrm>
           <a:prstGeom prst="rect">
@@ -15562,8 +15562,8 @@
         </p:nvSpPr>
         <p:spPr>
           <a:xfrm>
-            <a:off x="502920" y="4206240"/>
-            <a:ext cx="6903720" cy="2414015"/>
+            <a:off x="502920" y="4160520"/>
+            <a:ext cx="6903720" cy="2359152"/>
           </a:xfrm>
           <a:prstGeom prst="roundRect">
             <a:avLst>
@@ -15618,8 +15618,8 @@
         </p:blipFill>
         <p:spPr>
           <a:xfrm>
-            <a:off x="576072" y="4261103"/>
-            <a:ext cx="6757416" cy="1956815"/>
+            <a:off x="576072" y="4215383"/>
+            <a:ext cx="6757416" cy="1901952"/>
           </a:xfrm>
           <a:prstGeom prst="rect">
             <a:avLst/>
@@ -15634,7 +15634,7 @@
         </p:nvSpPr>
         <p:spPr>
           <a:xfrm>
-            <a:off x="576072" y="6336792"/>
+            <a:off x="576072" y="6236208"/>
             <a:ext cx="6757416" cy="256032"/>
           </a:xfrm>
           <a:prstGeom prst="rect">
@@ -15676,8 +15676,8 @@
         </p:nvSpPr>
         <p:spPr>
           <a:xfrm>
-            <a:off x="7543800" y="4206240"/>
-            <a:ext cx="4142232" cy="2414015"/>
+            <a:off x="7543800" y="4160520"/>
+            <a:ext cx="4142232" cy="2359152"/>
           </a:xfrm>
           <a:prstGeom prst="roundRect">
             <a:avLst>
@@ -15732,8 +15732,8 @@
         </p:blipFill>
         <p:spPr>
           <a:xfrm>
-            <a:off x="7616952" y="4261103"/>
-            <a:ext cx="3995928" cy="1956815"/>
+            <a:off x="7616952" y="4215383"/>
+            <a:ext cx="3995928" cy="1901952"/>
           </a:xfrm>
           <a:prstGeom prst="rect">
             <a:avLst/>
@@ -15748,7 +15748,7 @@
         </p:nvSpPr>
         <p:spPr>
           <a:xfrm>
-            <a:off x="7616952" y="6336792"/>
+            <a:off x="7616952" y="6236208"/>
             <a:ext cx="3995928" cy="256032"/>
           </a:xfrm>
           <a:prstGeom prst="rect">

</xml_diff>

<commit_message>
feat: add python script to generate 12-slide GCC Atlas strategy deck pptx
</commit_message>
<xml_diff>
--- a/product/deck/gcc-atlas-strategy-deck.pptx
+++ b/product/deck/gcc-atlas-strategy-deck.pptx
@@ -15563,7 +15563,7 @@
         <p:spPr>
           <a:xfrm>
             <a:off x="502920" y="4160520"/>
-            <a:ext cx="6903720" cy="2359152"/>
+            <a:ext cx="6903720" cy="2304288"/>
           </a:xfrm>
           <a:prstGeom prst="roundRect">
             <a:avLst>
@@ -15619,7 +15619,7 @@
         <p:spPr>
           <a:xfrm>
             <a:off x="576072" y="4215383"/>
-            <a:ext cx="6757416" cy="1901952"/>
+            <a:ext cx="6757416" cy="1847088"/>
           </a:xfrm>
           <a:prstGeom prst="rect">
             <a:avLst/>
@@ -15634,7 +15634,7 @@
         </p:nvSpPr>
         <p:spPr>
           <a:xfrm>
-            <a:off x="576072" y="6236208"/>
+            <a:off x="576072" y="6181344"/>
             <a:ext cx="6757416" cy="256032"/>
           </a:xfrm>
           <a:prstGeom prst="rect">
@@ -15677,7 +15677,7 @@
         <p:spPr>
           <a:xfrm>
             <a:off x="7543800" y="4160520"/>
-            <a:ext cx="4142232" cy="2359152"/>
+            <a:ext cx="4142232" cy="2304288"/>
           </a:xfrm>
           <a:prstGeom prst="roundRect">
             <a:avLst>
@@ -15733,7 +15733,7 @@
         <p:spPr>
           <a:xfrm>
             <a:off x="7616952" y="4215383"/>
-            <a:ext cx="3995928" cy="1901952"/>
+            <a:ext cx="3995928" cy="1847088"/>
           </a:xfrm>
           <a:prstGeom prst="rect">
             <a:avLst/>
@@ -15748,7 +15748,7 @@
         </p:nvSpPr>
         <p:spPr>
           <a:xfrm>
-            <a:off x="7616952" y="6236208"/>
+            <a:off x="7616952" y="6181344"/>
             <a:ext cx="3995928" cy="256032"/>
           </a:xfrm>
           <a:prstGeom prst="rect">

</xml_diff>